<commit_message>
Correct Binggrae sugar from detailed nutrition label and document review gap
</commit_message>
<xml_diff>
--- a/presentation/protein_value_analysis.pptx
+++ b/presentation/protein_value_analysis.pptx
@@ -181,7 +181,7 @@
             </c:spPr>
             <c:extLst>
               <c:ext xmlns:c16="http://schemas.microsoft.com/office/drawing/2014/chart" uri="{C3380CC4-5D6E-409C-BE32-E72D297353CC}">
-                <c16:uniqueId val="{00000001-EC70-40C7-9913-44E27F8DC52C}"/>
+                <c16:uniqueId val="{00000001-CDEA-4672-9BE3-C79EDAC3D1B5}"/>
               </c:ext>
             </c:extLst>
           </c:dPt>
@@ -199,7 +199,7 @@
             </c:spPr>
             <c:extLst>
               <c:ext xmlns:c16="http://schemas.microsoft.com/office/drawing/2014/chart" uri="{C3380CC4-5D6E-409C-BE32-E72D297353CC}">
-                <c16:uniqueId val="{00000003-EC70-40C7-9913-44E27F8DC52C}"/>
+                <c16:uniqueId val="{00000003-CDEA-4672-9BE3-C79EDAC3D1B5}"/>
               </c:ext>
             </c:extLst>
           </c:dPt>
@@ -217,7 +217,7 @@
             </c:spPr>
             <c:extLst>
               <c:ext xmlns:c16="http://schemas.microsoft.com/office/drawing/2014/chart" uri="{C3380CC4-5D6E-409C-BE32-E72D297353CC}">
-                <c16:uniqueId val="{00000005-EC70-40C7-9913-44E27F8DC52C}"/>
+                <c16:uniqueId val="{00000005-CDEA-4672-9BE3-C79EDAC3D1B5}"/>
               </c:ext>
             </c:extLst>
           </c:dPt>
@@ -235,7 +235,7 @@
             </c:spPr>
             <c:extLst>
               <c:ext xmlns:c16="http://schemas.microsoft.com/office/drawing/2014/chart" uri="{C3380CC4-5D6E-409C-BE32-E72D297353CC}">
-                <c16:uniqueId val="{00000007-EC70-40C7-9913-44E27F8DC52C}"/>
+                <c16:uniqueId val="{00000007-CDEA-4672-9BE3-C79EDAC3D1B5}"/>
               </c:ext>
             </c:extLst>
           </c:dPt>
@@ -253,7 +253,7 @@
             </c:spPr>
             <c:extLst>
               <c:ext xmlns:c16="http://schemas.microsoft.com/office/drawing/2014/chart" uri="{C3380CC4-5D6E-409C-BE32-E72D297353CC}">
-                <c16:uniqueId val="{00000009-EC70-40C7-9913-44E27F8DC52C}"/>
+                <c16:uniqueId val="{00000009-CDEA-4672-9BE3-C79EDAC3D1B5}"/>
               </c:ext>
             </c:extLst>
           </c:dPt>
@@ -339,7 +339,7 @@
           </c:val>
           <c:extLst>
             <c:ext xmlns:c16="http://schemas.microsoft.com/office/drawing/2014/chart" uri="{C3380CC4-5D6E-409C-BE32-E72D297353CC}">
-              <c16:uniqueId val="{0000000A-EC70-40C7-9913-44E27F8DC52C}"/>
+              <c16:uniqueId val="{0000000A-CDEA-4672-9BE3-C79EDAC3D1B5}"/>
             </c:ext>
           </c:extLst>
         </c:ser>
@@ -485,7 +485,7 @@
             </c:spPr>
             <c:extLst>
               <c:ext xmlns:c16="http://schemas.microsoft.com/office/drawing/2014/chart" uri="{C3380CC4-5D6E-409C-BE32-E72D297353CC}">
-                <c16:uniqueId val="{00000001-431F-479E-984C-2FDEFD9133A7}"/>
+                <c16:uniqueId val="{00000001-467A-4AB0-B86D-0469423F586F}"/>
               </c:ext>
             </c:extLst>
           </c:dPt>
@@ -503,7 +503,7 @@
             </c:spPr>
             <c:extLst>
               <c:ext xmlns:c16="http://schemas.microsoft.com/office/drawing/2014/chart" uri="{C3380CC4-5D6E-409C-BE32-E72D297353CC}">
-                <c16:uniqueId val="{00000003-431F-479E-984C-2FDEFD9133A7}"/>
+                <c16:uniqueId val="{00000003-467A-4AB0-B86D-0469423F586F}"/>
               </c:ext>
             </c:extLst>
           </c:dPt>
@@ -521,7 +521,7 @@
             </c:spPr>
             <c:extLst>
               <c:ext xmlns:c16="http://schemas.microsoft.com/office/drawing/2014/chart" uri="{C3380CC4-5D6E-409C-BE32-E72D297353CC}">
-                <c16:uniqueId val="{00000005-431F-479E-984C-2FDEFD9133A7}"/>
+                <c16:uniqueId val="{00000005-467A-4AB0-B86D-0469423F586F}"/>
               </c:ext>
             </c:extLst>
           </c:dPt>
@@ -539,7 +539,7 @@
             </c:spPr>
             <c:extLst>
               <c:ext xmlns:c16="http://schemas.microsoft.com/office/drawing/2014/chart" uri="{C3380CC4-5D6E-409C-BE32-E72D297353CC}">
-                <c16:uniqueId val="{00000007-431F-479E-984C-2FDEFD9133A7}"/>
+                <c16:uniqueId val="{00000007-467A-4AB0-B86D-0469423F586F}"/>
               </c:ext>
             </c:extLst>
           </c:dPt>
@@ -557,7 +557,7 @@
             </c:spPr>
             <c:extLst>
               <c:ext xmlns:c16="http://schemas.microsoft.com/office/drawing/2014/chart" uri="{C3380CC4-5D6E-409C-BE32-E72D297353CC}">
-                <c16:uniqueId val="{00000009-431F-479E-984C-2FDEFD9133A7}"/>
+                <c16:uniqueId val="{00000009-467A-4AB0-B86D-0469423F586F}"/>
               </c:ext>
             </c:extLst>
           </c:dPt>
@@ -643,7 +643,7 @@
           </c:val>
           <c:extLst>
             <c:ext xmlns:c16="http://schemas.microsoft.com/office/drawing/2014/chart" uri="{C3380CC4-5D6E-409C-BE32-E72D297353CC}">
-              <c16:uniqueId val="{0000000A-431F-479E-984C-2FDEFD9133A7}"/>
+              <c16:uniqueId val="{0000000A-467A-4AB0-B86D-0469423F586F}"/>
             </c:ext>
           </c:extLst>
         </c:ser>
@@ -771,7 +771,7 @@
     </p:spTree>
     <p:extLst>
       <p:ext uri="{BB962C8B-B14F-4D97-AF65-F5344CB8AC3E}">
-        <p14:creationId xmlns:p14="http://schemas.microsoft.com/office/powerpoint/2010/main" val="2853389866"/>
+        <p14:creationId xmlns:p14="http://schemas.microsoft.com/office/powerpoint/2010/main" val="3184190618"/>
       </p:ext>
     </p:extLst>
   </p:cSld>
@@ -1636,6 +1636,21 @@
           </a:p>
           <a:p>
             <a:r>
+              <a:t>[C02] 더단백 초코 250mL 상세 영양표: 당류 0.8g·단백질 20g·105kcal</a:t>
+            </a:r>
+          </a:p>
+          <a:p>
+            <a:r>
+              <a:t>https://www.coupang.com/vp/products/7411095382?itemId=13466502453&amp;vendorItemId=76137436686</a:t>
+            </a:r>
+          </a:p>
+          <a:p>
+            <a:r>
+              <a:t>게시 게시일 미표기 / 수집 2026-10-18</a:t>
+            </a:r>
+          </a:p>
+          <a:p>
+            <a:r>
               <a:t>[M01] 매일유업 공식 제품 영양정보</a:t>
             </a:r>
           </a:p>
@@ -2812,7 +2827,7 @@
           <a:lstStyle/>
           <a:p>
             <a:r>
-              <a:t>셀렉스는 공식 100% WPI 원료 사용 안내, 마이밀은 가격비교 자료의 분리대두·완두·귀리 단백질 안내를 확인했다. 100% WPI라는 말은 음료 전체가 단백질이라는 뜻이 아니다. 다른 제품 원료 유형을 추정하지 않았다. 당류는 셀렉스 0g, 그린비아 1g, 오트몬드 0g을 확보했고 나머지 2개는 이번 채택 근거에서 미확보로 남겼다.</a:t>
+              <a:t>최초 조사에서 더단백 상품 요약에 당류가 없다는 이유로 상세 이미지까지 확인하지 않고 미확보로 처리했다. 사용자 제공 쿠팡 상세 라벨에서 250mL·105kcal·단백질20g·당류0.8g을 확인해 정정했다. 셀렉스는 공식 0g, 그린비아는 재게시 1g, 오트몬드는 재게시 0g이다. 마이밀은 현재 판매 구성의 상세 라벨 검토가 아직 완료되지 않은 상태이며 정보가 공개되지 않았다는 뜻이 아니다. 100% WPI 원료 사용이라는 말은 음료 전체가 단백질이라는 뜻이 아니며 원료 유형을 우열 점수로 바꾸지 않았다.</a:t>
             </a:r>
           </a:p>
           <a:p>
@@ -2876,6 +2891,21 @@
           <a:p>
             <a:r>
               <a:t>게시 게시일 미표기 / 수집 2026-10-18T11:14:34.525091+00:00</a:t>
+            </a:r>
+          </a:p>
+          <a:p>
+            <a:r>
+              <a:t>[C02] 더단백 초코 250mL 상세 영양표: 당류 0.8g·단백질 20g·105kcal</a:t>
+            </a:r>
+          </a:p>
+          <a:p>
+            <a:r>
+              <a:t>https://www.coupang.com/vp/products/7411095382?itemId=13466502453&amp;vendorItemId=76137436686</a:t>
+            </a:r>
+          </a:p>
+          <a:p>
+            <a:r>
+              <a:t>게시 게시일 미표기 / 수집 2026-10-18</a:t>
             </a:r>
           </a:p>
           <a:p>
@@ -7797,7 +7827,7 @@
               </a:defRPr>
             </a:pPr>
             <a:r>
-              <a:t>D01 · D02 · D03 · D04 · D05 · D06 · C01 · M01 · N01 · M02 · K01 | 수집 2026.10.18 · 공개 표시값·관측 구성 한정</a:t>
+              <a:t>D01 · D02 · D03 · D04 · D05 · D06 · C01 · C02 · M01 · N01 · M02 · K01 | 수집 2026.10.18 · 공개 표시값·관측 구성 한정</a:t>
             </a:r>
           </a:p>
         </p:txBody>
@@ -8131,6 +8161,48 @@
             </a:pPr>
             <a:r>
               <a:rPr>
+                <a:hlinkClick r:id="rId9"/>
+              </a:rPr>
+              <a:t>[C02] 더단백 초코 250mL 상세 영양표: 당류 0.8g·단백질 20g·10</a:t>
+            </a:r>
+          </a:p>
+        </p:txBody>
+      </p:sp>
+      <p:sp>
+        <p:nvSpPr>
+          <p:cNvPr id="15" name="TextBox 14"/>
+          <p:cNvSpPr txBox="1"/>
+          <p:nvPr/>
+        </p:nvSpPr>
+        <p:spPr>
+          <a:xfrm>
+            <a:off x="6400800" y="3675887"/>
+            <a:ext cx="5440680" cy="393192"/>
+          </a:xfrm>
+          <a:prstGeom prst="rect">
+            <a:avLst/>
+          </a:prstGeom>
+          <a:noFill/>
+        </p:spPr>
+        <p:txBody>
+          <a:bodyPr wrap="square" lIns="0" tIns="0" rIns="0" bIns="0">
+            <a:spAutoFit/>
+          </a:bodyPr>
+          <a:lstStyle/>
+          <a:p>
+            <a:pPr>
+              <a:spcAft>
+                <a:spcPts val="800"/>
+              </a:spcAft>
+              <a:defRPr sz="1100" b="1">
+                <a:solidFill>
+                  <a:srgbClr val="122523"/>
+                </a:solidFill>
+                <a:latin typeface="맑은 고딕"/>
+              </a:defRPr>
+            </a:pPr>
+            <a:r>
+              <a:rPr>
                 <a:hlinkClick r:id="rId10"/>
               </a:rPr>
               <a:t>[M01] 매일유업 공식 제품 영양정보</a:t>
@@ -8140,13 +8212,13 @@
       </p:sp>
       <p:sp>
         <p:nvSpPr>
-          <p:cNvPr id="15" name="TextBox 14"/>
-          <p:cNvSpPr txBox="1"/>
-          <p:nvPr/>
-        </p:nvSpPr>
-        <p:spPr>
-          <a:xfrm>
-            <a:off x="6400800" y="3675887"/>
+          <p:cNvPr id="16" name="TextBox 15"/>
+          <p:cNvSpPr txBox="1"/>
+          <p:nvPr/>
+        </p:nvSpPr>
+        <p:spPr>
+          <a:xfrm>
+            <a:off x="6400800" y="4142232"/>
             <a:ext cx="5440680" cy="393192"/>
           </a:xfrm>
           <a:prstGeom prst="rect">
@@ -8182,13 +8254,13 @@
       </p:sp>
       <p:sp>
         <p:nvSpPr>
-          <p:cNvPr id="16" name="TextBox 15"/>
-          <p:cNvSpPr txBox="1"/>
-          <p:nvPr/>
-        </p:nvSpPr>
-        <p:spPr>
-          <a:xfrm>
-            <a:off x="6400800" y="4142232"/>
+          <p:cNvPr id="17" name="TextBox 16"/>
+          <p:cNvSpPr txBox="1"/>
+          <p:nvPr/>
+        </p:nvSpPr>
+        <p:spPr>
+          <a:xfrm>
+            <a:off x="6400800" y="4608576"/>
             <a:ext cx="5440680" cy="393192"/>
           </a:xfrm>
           <a:prstGeom prst="rect">
@@ -8224,13 +8296,13 @@
       </p:sp>
       <p:sp>
         <p:nvSpPr>
-          <p:cNvPr id="17" name="TextBox 16"/>
-          <p:cNvSpPr txBox="1"/>
-          <p:nvPr/>
-        </p:nvSpPr>
-        <p:spPr>
-          <a:xfrm>
-            <a:off x="6400800" y="4608576"/>
+          <p:cNvPr id="18" name="TextBox 17"/>
+          <p:cNvSpPr txBox="1"/>
+          <p:nvPr/>
+        </p:nvSpPr>
+        <p:spPr>
+          <a:xfrm>
+            <a:off x="6400800" y="5074920"/>
             <a:ext cx="5440680" cy="393192"/>
           </a:xfrm>
           <a:prstGeom prst="rect">
@@ -8266,7 +8338,7 @@
       </p:sp>
       <p:sp>
         <p:nvSpPr>
-          <p:cNvPr id="18" name="TextBox 17"/>
+          <p:cNvPr id="19" name="TextBox 18"/>
           <p:cNvSpPr txBox="1"/>
           <p:nvPr/>
         </p:nvSpPr>
@@ -9255,7 +9327,7 @@
               </a:defRPr>
             </a:pPr>
             <a:r>
-              <a:t>reported</a:t>
+              <a:t>verified</a:t>
             </a:r>
           </a:p>
         </p:txBody>
@@ -12010,7 +12082,7 @@
               </a:defRPr>
             </a:pPr>
             <a:r>
-              <a:t>품질 점수 대신, 확인한 성분과 빈칸을 보여준다</a:t>
+              <a:t>상세 영양표까지 확인해야 누락을 줄일 수 있다</a:t>
             </a:r>
           </a:p>
         </p:txBody>
@@ -12049,7 +12121,7 @@
               </a:defRPr>
             </a:pPr>
             <a:r>
-              <a:t>단백질·열량·당류·원료 유형은 다른 정보다</a:t>
+              <a:t>더단백 당류 0.8g 반영 · 상품 요약만 보고 미확보로 처리했던 오류 정정</a:t>
             </a:r>
           </a:p>
         </p:txBody>
@@ -12127,7 +12199,7 @@
               </a:defRPr>
             </a:pPr>
             <a:r>
-              <a:t>D02 · D04 · D05 · D06 · M01 | 수집 2026.10.18 · 공개 표시값·관측 구성 한정</a:t>
+              <a:t>C02 · D02 · D04 · D05 · D06 · M01 | 수집 2026.10.18 · 공개 표시값·관측 구성 한정</a:t>
             </a:r>
           </a:p>
         </p:txBody>
@@ -12439,7 +12511,7 @@
               </a:defRPr>
             </a:pPr>
             <a:r>
-              <a:t>당류 미확보</a:t>
+              <a:t>당류 0.8g</a:t>
             </a:r>
           </a:p>
         </p:txBody>
@@ -12751,7 +12823,7 @@
               </a:defRPr>
             </a:pPr>
             <a:r>
-              <a:t>당류 미확보</a:t>
+              <a:t>상세 라벨 미검증</a:t>
             </a:r>
           </a:p>
         </p:txBody>

</xml_diff>